<commit_message>
Update presentation app link
</commit_message>
<xml_diff>
--- a/ambulance response time - omir gibreel.pptx
+++ b/ambulance response time - omir gibreel.pptx
@@ -6198,19 +6198,20 @@
                 <a:latin typeface="Arial"/>
                 <a:cs typeface="Arial"/>
               </a:rPr>
-              <a:t>بعد النشر اليدوي على Streamlit Community Cloud ضع الرابط النهائي هنا:</a:t>
+              <a:t>رابط التطبيق النهائي على Streamlit Community Cloud:</a:t>
             </a:r>
           </a:p>
           <a:p>
             <a:pPr algn="ctr"/>
             <a:r>
               <a:rPr lang="en-US" sz="2400" b="1">
+                <a:hlinkClick r:id="rId2"/>
                 <a:solidFill>
                   <a:srgbClr val="0F766E"/>
                 </a:solidFill>
                 <a:latin typeface="Arial"/>
               </a:rPr>
-              <a:t>https://your-app-name.streamlit.app</a:t>
+              <a:t>https://ambulance-response-time-ml.streamlit.app/</a:t>
             </a:r>
           </a:p>
         </p:txBody>
@@ -6255,7 +6256,7 @@
                 <a:latin typeface="Arial"/>
                 <a:cs typeface="Arial"/>
               </a:rPr>
-              <a:t>هذه الشريحة مخصصة لوضع الرابط النهائي بعد اكتمال النشر اليدوي.</a:t>
+              <a:t>يمكن فتح التطبيق مباشرة من الرابط أعلاه لتجربة التنبؤات باللغة العربية.</a:t>
             </a:r>
           </a:p>
         </p:txBody>

</xml_diff>